<commit_message>
UI restyle, part 2: no emoji in core, skills, docs and decks; cover KPI fix
- source tiers in text and prompts are words (Open data, Uploaded, Internal, flagged)
  everywhere the Copilot, the brief, the information agent and the docs produce them
- decks: tier colours as 7pt dots with labels (deals table, Sources legend), navy-gold
  theme on the token colours (#1B3A5C / #B9781A), template rebuilt
- cover: KPI tiles only where a value exists, rules masked and re-centred otherwise;
  placeholder wording ("none added yet") never reaches a cover; check_deck reports both
- brief byline no longer says "none added yet"; sample decks and PDFs regenerated
- test for the cover; 68 tests

Co-Authored-By: Claude Fable 5.1 <noreply@anthropic.com>
Claude-Session: https://claude.ai/code/session_01VssUfiVQ3tn9b1dVnCTiLG
</commit_message>
<xml_diff>
--- a/docs/samples/client-update-forest-cream-sample.pptx
+++ b/docs/samples/client-update-forest-cream-sample.pptx
@@ -8123,7 +8123,7 @@
           <a:p>
             <a:r>
               <a:rPr/>
-              <a:t>Top team signals (none added yet)</a:t>
+              <a:t>Board brief  ·  figures to Q2 2026  ·  10 Oct 2026</a:t>
             </a:r>
           </a:p>
         </p:txBody>
@@ -8202,6 +8202,14 @@
                   <a:srgbClr val="C8D2CA"/>
                 </a:solidFill>
               </a:rPr>
+              <a:t/>
+            </a:r>
+            <a:r>
+              <a:rPr sz="1000">
+                <a:solidFill>
+                  <a:srgbClr val="C8D2CA"/>
+                </a:solidFill>
+              </a:rPr>
               <a:t> [1]</a:t>
             </a:r>
           </a:p>
@@ -8257,6 +8265,14 @@
                   <a:srgbClr val="C8D2CA"/>
                 </a:solidFill>
               </a:rPr>
+              <a:t/>
+            </a:r>
+            <a:r>
+              <a:rPr sz="1000">
+                <a:solidFill>
+                  <a:srgbClr val="C8D2CA"/>
+                </a:solidFill>
+              </a:rPr>
               <a:t> [1]</a:t>
             </a:r>
           </a:p>
@@ -8312,6 +8328,14 @@
                   <a:srgbClr val="C8D2CA"/>
                 </a:solidFill>
               </a:rPr>
+              <a:t/>
+            </a:r>
+            <a:r>
+              <a:rPr sz="1000">
+                <a:solidFill>
+                  <a:srgbClr val="C8D2CA"/>
+                </a:solidFill>
+              </a:rPr>
               <a:t> [1]</a:t>
             </a:r>
           </a:p>
@@ -8360,6 +8384,14 @@
                 <a:latin typeface="Georgia"/>
               </a:rPr>
               <a:t>3.75%</a:t>
+            </a:r>
+            <a:r>
+              <a:rPr sz="1000">
+                <a:solidFill>
+                  <a:srgbClr val="C8D2CA"/>
+                </a:solidFill>
+              </a:rPr>
+              <a:t/>
             </a:r>
             <a:r>
               <a:rPr sz="1000">
@@ -10036,7 +10068,12 @@
             <p:ph type="body" idx="105"/>
           </p:nvPr>
         </p:nvSpPr>
-        <p:spPr/>
+        <p:spPr>
+          <a:xfrm>
+            <a:off x="548640" y="1645920"/>
+            <a:ext cx="11064240" cy="4389120"/>
+          </a:xfrm>
+        </p:spPr>
         <p:txBody>
           <a:bodyPr wrap="square"/>
           <a:lstStyle/>
@@ -10103,12 +10140,6 @@
           <a:p>
             <a:r>
               <a:rPr/>
-              <a:t>[11] Knight Frank research (seed) (2025-12-31) - https://www.knightfrank.co.uk/site-assets/research/report-pdfs/spotlight/spotlight-q4-2025-2.pdf</a:t>
-            </a:r>
-          </a:p>
-          <a:p>
-            <a:r>
-              <a:rPr/>
               <a:t/>
             </a:r>
           </a:p>
@@ -10122,21 +10153,239 @@
               <a:t>Figures restated from public research for this proof of concept (Knight Frank terms bar AI use of their data); verify against the original before external use.</a:t>
             </a:r>
           </a:p>
-          <a:p>
-            <a:r>
-              <a:rPr>
+        </p:txBody>
+      </p:sp>
+      <p:sp>
+        <p:nvSpPr>
+          <p:cNvPr id="5" name="tier dot open"/>
+          <p:cNvSpPr/>
+          <p:nvPr/>
+        </p:nvSpPr>
+        <p:spPr>
+          <a:xfrm>
+            <a:off x="548640" y="6227064"/>
+            <a:ext cx="88900" cy="88900"/>
+          </a:xfrm>
+          <a:prstGeom prst="ellipse">
+            <a:avLst/>
+          </a:prstGeom>
+          <a:solidFill>
+            <a:srgbClr val="2E7D55"/>
+          </a:solidFill>
+          <a:ln>
+            <a:noFill/>
+          </a:ln>
+        </p:spPr>
+        <p:style>
+          <a:lnRef idx="1">
+            <a:schemeClr val="accent1"/>
+          </a:lnRef>
+          <a:fillRef idx="3">
+            <a:schemeClr val="accent1"/>
+          </a:fillRef>
+          <a:effectRef idx="2">
+            <a:schemeClr val="accent1"/>
+          </a:effectRef>
+          <a:fontRef idx="minor">
+            <a:schemeClr val="lt1"/>
+          </a:fontRef>
+        </p:style>
+        <p:txBody>
+          <a:bodyPr rtlCol="0" anchor="ctr"/>
+          <a:lstStyle/>
+          <a:p>
+            <a:pPr algn="ctr"/>
+          </a:p>
+        </p:txBody>
+      </p:sp>
+      <p:sp>
+        <p:nvSpPr>
+          <p:cNvPr id="6" name="TextBox 5"/>
+          <p:cNvSpPr txBox="1"/>
+          <p:nvPr/>
+        </p:nvSpPr>
+        <p:spPr>
+          <a:xfrm>
+            <a:off x="675640" y="6144768"/>
+            <a:ext cx="2138679" cy="228600"/>
+          </a:xfrm>
+          <a:prstGeom prst="rect">
+            <a:avLst/>
+          </a:prstGeom>
+          <a:noFill/>
+        </p:spPr>
+        <p:txBody>
+          <a:bodyPr wrap="square" lIns="0" rIns="0">
+            <a:spAutoFit/>
+          </a:bodyPr>
+          <a:lstStyle/>
+          <a:p>
+            <a:r>
+              <a:rPr sz="900">
                 <a:solidFill>
                   <a:srgbClr val="6C7268"/>
                 </a:solidFill>
               </a:rPr>
-              <a:t>🟢 collected automatically from open data · 🟠 uploaded by a colleague under the team's own access</a:t>
-            </a:r>
-          </a:p>
-        </p:txBody>
-      </p:sp>
-      <p:sp>
-        <p:nvSpPr>
-          <p:cNvPr id="5" name="TextBox 4"/>
+              <a:t>Open data, collected automatically</a:t>
+            </a:r>
+          </a:p>
+        </p:txBody>
+      </p:sp>
+      <p:sp>
+        <p:nvSpPr>
+          <p:cNvPr id="7" name="tier dot uploaded"/>
+          <p:cNvSpPr/>
+          <p:nvPr/>
+        </p:nvSpPr>
+        <p:spPr>
+          <a:xfrm>
+            <a:off x="2997199" y="6227064"/>
+            <a:ext cx="88900" cy="88900"/>
+          </a:xfrm>
+          <a:prstGeom prst="ellipse">
+            <a:avLst/>
+          </a:prstGeom>
+          <a:solidFill>
+            <a:srgbClr val="B9781A"/>
+          </a:solidFill>
+          <a:ln>
+            <a:noFill/>
+          </a:ln>
+        </p:spPr>
+        <p:style>
+          <a:lnRef idx="1">
+            <a:schemeClr val="accent1"/>
+          </a:lnRef>
+          <a:fillRef idx="3">
+            <a:schemeClr val="accent1"/>
+          </a:fillRef>
+          <a:effectRef idx="2">
+            <a:schemeClr val="accent1"/>
+          </a:effectRef>
+          <a:fontRef idx="minor">
+            <a:schemeClr val="lt1"/>
+          </a:fontRef>
+        </p:style>
+        <p:txBody>
+          <a:bodyPr rtlCol="0" anchor="ctr"/>
+          <a:lstStyle/>
+          <a:p>
+            <a:pPr algn="ctr"/>
+          </a:p>
+        </p:txBody>
+      </p:sp>
+      <p:sp>
+        <p:nvSpPr>
+          <p:cNvPr id="8" name="TextBox 7"/>
+          <p:cNvSpPr txBox="1"/>
+          <p:nvPr/>
+        </p:nvSpPr>
+        <p:spPr>
+          <a:xfrm>
+            <a:off x="3124199" y="6144768"/>
+            <a:ext cx="3131820" cy="228600"/>
+          </a:xfrm>
+          <a:prstGeom prst="rect">
+            <a:avLst/>
+          </a:prstGeom>
+          <a:noFill/>
+        </p:spPr>
+        <p:txBody>
+          <a:bodyPr wrap="square" lIns="0" rIns="0">
+            <a:spAutoFit/>
+          </a:bodyPr>
+          <a:lstStyle/>
+          <a:p>
+            <a:r>
+              <a:rPr sz="900">
+                <a:solidFill>
+                  <a:srgbClr val="6C7268"/>
+                </a:solidFill>
+              </a:rPr>
+              <a:t>Uploaded by a colleague under the team's own access</a:t>
+            </a:r>
+          </a:p>
+        </p:txBody>
+      </p:sp>
+      <p:sp>
+        <p:nvSpPr>
+          <p:cNvPr id="9" name="tier dot internal"/>
+          <p:cNvSpPr/>
+          <p:nvPr/>
+        </p:nvSpPr>
+        <p:spPr>
+          <a:xfrm>
+            <a:off x="6438899" y="6227064"/>
+            <a:ext cx="88900" cy="88900"/>
+          </a:xfrm>
+          <a:prstGeom prst="ellipse">
+            <a:avLst/>
+          </a:prstGeom>
+          <a:solidFill>
+            <a:srgbClr val="2F6FBF"/>
+          </a:solidFill>
+          <a:ln>
+            <a:noFill/>
+          </a:ln>
+        </p:spPr>
+        <p:style>
+          <a:lnRef idx="1">
+            <a:schemeClr val="accent1"/>
+          </a:lnRef>
+          <a:fillRef idx="3">
+            <a:schemeClr val="accent1"/>
+          </a:fillRef>
+          <a:effectRef idx="2">
+            <a:schemeClr val="accent1"/>
+          </a:effectRef>
+          <a:fontRef idx="minor">
+            <a:schemeClr val="lt1"/>
+          </a:fontRef>
+        </p:style>
+        <p:txBody>
+          <a:bodyPr rtlCol="0" anchor="ctr"/>
+          <a:lstStyle/>
+          <a:p>
+            <a:pPr algn="ctr"/>
+          </a:p>
+        </p:txBody>
+      </p:sp>
+      <p:sp>
+        <p:nvSpPr>
+          <p:cNvPr id="10" name="TextBox 9"/>
+          <p:cNvSpPr txBox="1"/>
+          <p:nvPr/>
+        </p:nvSpPr>
+        <p:spPr>
+          <a:xfrm>
+            <a:off x="6565899" y="6144768"/>
+            <a:ext cx="1612899" cy="228600"/>
+          </a:xfrm>
+          <a:prstGeom prst="rect">
+            <a:avLst/>
+          </a:prstGeom>
+          <a:noFill/>
+        </p:spPr>
+        <p:txBody>
+          <a:bodyPr wrap="square" lIns="0" rIns="0">
+            <a:spAutoFit/>
+          </a:bodyPr>
+          <a:lstStyle/>
+          <a:p>
+            <a:r>
+              <a:rPr sz="900">
+                <a:solidFill>
+                  <a:srgbClr val="6C7268"/>
+                </a:solidFill>
+              </a:rPr>
+              <a:t>Internal, our own records</a:t>
+            </a:r>
+          </a:p>
+        </p:txBody>
+      </p:sp>
+      <p:sp>
+        <p:nvSpPr>
+          <p:cNvPr id="11" name="TextBox 10"/>
           <p:cNvSpPr txBox="1"/>
           <p:nvPr/>
         </p:nvSpPr>

</xml_diff>

<commit_message>
Add the app logo and the Nan Fung co-brand (direction A, skyline)
Sidebar header carries the horizontal logo with a "Prototype · sample data"
caption, the sidebar foot the official Nan Fung Group mark under "Built for",
the Team brief preview the co-brand lockup, the browser tab the favicon.
Deck covers carry the co-brand lockup top right on every theme (a transparent
render of the on-navy file) and content slides the small app icon beside the
slide number. Brand files, placement rules and the trademark note live in
assets/brand/README.md; sample decks and screenshots regenerated.

Co-Authored-By: Claude Fable 5.1 <noreply@anthropic.com>
Claude-Session: https://claude.ai/code/session_01VssUfiVQ3tn9b1dVnCTiLG
</commit_message>
<xml_diff>
--- a/docs/samples/client-update-forest-cream-sample.pptx
+++ b/docs/samples/client-update-forest-cream-sample.pptx
@@ -8123,7 +8123,7 @@
           <a:p>
             <a:r>
               <a:rPr/>
-              <a:t>Board brief  ·  figures to Q2 2026  ·  10 Oct 2026</a:t>
+              <a:t>Board brief  ·  figures to Q2 2026  ·  11 Oct 2026</a:t>
             </a:r>
           </a:p>
         </p:txBody>
@@ -8436,6 +8436,30 @@
           </a:p>
         </p:txBody>
       </p:sp>
+      <p:pic>
+        <p:nvPicPr>
+          <p:cNvPr id="11" name="co-brand" descr="cobrand-nanfung-on-dark@2x.png"/>
+          <p:cNvPicPr>
+            <a:picLocks noChangeAspect="1"/>
+          </p:cNvPicPr>
+          <p:nvPr/>
+        </p:nvPicPr>
+        <p:blipFill>
+          <a:blip r:embed="rId2"/>
+          <a:stretch>
+            <a:fillRect/>
+          </a:stretch>
+        </p:blipFill>
+        <p:spPr>
+          <a:xfrm>
+            <a:off x="8457914" y="347472"/>
+            <a:ext cx="3203734" cy="566928"/>
+          </a:xfrm>
+          <a:prstGeom prst="rect">
+            <a:avLst/>
+          </a:prstGeom>
+        </p:spPr>
+      </p:pic>
     </p:spTree>
   </p:cSld>
   <p:clrMapOvr>
@@ -8528,6 +8552,30 @@
           </a:p>
         </p:txBody>
       </p:sp>
+      <p:pic>
+        <p:nvPicPr>
+          <p:cNvPr id="5" name="app icon" descr="app-icon-1024.png"/>
+          <p:cNvPicPr>
+            <a:picLocks noChangeAspect="1"/>
+          </p:cNvPicPr>
+          <p:nvPr/>
+        </p:nvPicPr>
+        <p:blipFill>
+          <a:blip r:embed="rId2"/>
+          <a:stretch>
+            <a:fillRect/>
+          </a:stretch>
+        </p:blipFill>
+        <p:spPr>
+          <a:xfrm>
+            <a:off x="10607040" y="6455664"/>
+            <a:ext cx="274320" cy="274320"/>
+          </a:xfrm>
+          <a:prstGeom prst="rect">
+            <a:avLst/>
+          </a:prstGeom>
+        </p:spPr>
+      </p:pic>
     </p:spTree>
   </p:cSld>
   <p:clrMapOvr>
@@ -8904,7 +8952,7 @@
         </p:xfrm>
         <a:graphic>
           <a:graphicData uri="http://schemas.openxmlformats.org/drawingml/2006/chart">
-            <c:chart xmlns:c="http://schemas.openxmlformats.org/drawingml/2006/chart" r:id="rId2"/>
+            <c:chart xmlns:c="http://schemas.openxmlformats.org/drawingml/2006/chart" r:id="rId3"/>
           </a:graphicData>
         </a:graphic>
       </p:graphicFrame>
@@ -8930,9 +8978,33 @@
           </a:p>
         </p:txBody>
       </p:sp>
-      <p:sp>
-        <p:nvSpPr>
-          <p:cNvPr id="19" name="Rectangle 18"/>
+      <p:pic>
+        <p:nvPicPr>
+          <p:cNvPr id="19" name="app icon" descr="app-icon-1024.png"/>
+          <p:cNvPicPr>
+            <a:picLocks noChangeAspect="1"/>
+          </p:cNvPicPr>
+          <p:nvPr/>
+        </p:nvPicPr>
+        <p:blipFill>
+          <a:blip r:embed="rId2"/>
+          <a:stretch>
+            <a:fillRect/>
+          </a:stretch>
+        </p:blipFill>
+        <p:spPr>
+          <a:xfrm>
+            <a:off x="10607040" y="6455664"/>
+            <a:ext cx="274320" cy="274320"/>
+          </a:xfrm>
+          <a:prstGeom prst="rect">
+            <a:avLst/>
+          </a:prstGeom>
+        </p:spPr>
+      </p:pic>
+      <p:sp>
+        <p:nvSpPr>
+          <p:cNvPr id="20" name="Rectangle 19"/>
           <p:cNvSpPr/>
           <p:nvPr/>
         </p:nvSpPr>
@@ -8991,7 +9063,7 @@
       </p:sp>
       <p:sp>
         <p:nvSpPr>
-          <p:cNvPr id="20" name="TextBox 19"/>
+          <p:cNvPr id="21" name="TextBox 20"/>
           <p:cNvSpPr txBox="1"/>
           <p:nvPr/>
         </p:nvSpPr>
@@ -9217,9 +9289,33 @@
           </a:p>
         </p:txBody>
       </p:sp>
-      <p:sp>
-        <p:nvSpPr>
-          <p:cNvPr id="10" name="Rectangle 9"/>
+      <p:pic>
+        <p:nvPicPr>
+          <p:cNvPr id="10" name="app icon" descr="app-icon-1024.png"/>
+          <p:cNvPicPr>
+            <a:picLocks noChangeAspect="1"/>
+          </p:cNvPicPr>
+          <p:nvPr/>
+        </p:nvPicPr>
+        <p:blipFill>
+          <a:blip r:embed="rId2"/>
+          <a:stretch>
+            <a:fillRect/>
+          </a:stretch>
+        </p:blipFill>
+        <p:spPr>
+          <a:xfrm>
+            <a:off x="10607040" y="6455664"/>
+            <a:ext cx="274320" cy="274320"/>
+          </a:xfrm>
+          <a:prstGeom prst="rect">
+            <a:avLst/>
+          </a:prstGeom>
+        </p:spPr>
+      </p:pic>
+      <p:sp>
+        <p:nvSpPr>
+          <p:cNvPr id="11" name="Rectangle 10"/>
           <p:cNvSpPr/>
           <p:nvPr/>
         </p:nvSpPr>
@@ -9278,7 +9374,7 @@
       </p:sp>
       <p:sp>
         <p:nvSpPr>
-          <p:cNvPr id="11" name="TextBox 10"/>
+          <p:cNvPr id="12" name="TextBox 11"/>
           <p:cNvSpPr txBox="1"/>
           <p:nvPr/>
         </p:nvSpPr>
@@ -9702,9 +9798,33 @@
           </a:p>
         </p:txBody>
       </p:sp>
+      <p:pic>
+        <p:nvPicPr>
+          <p:cNvPr id="19" name="app icon" descr="app-icon-1024.png"/>
+          <p:cNvPicPr>
+            <a:picLocks noChangeAspect="1"/>
+          </p:cNvPicPr>
+          <p:nvPr/>
+        </p:nvPicPr>
+        <p:blipFill>
+          <a:blip r:embed="rId2"/>
+          <a:stretch>
+            <a:fillRect/>
+          </a:stretch>
+        </p:blipFill>
+        <p:spPr>
+          <a:xfrm>
+            <a:off x="10607040" y="6455664"/>
+            <a:ext cx="274320" cy="274320"/>
+          </a:xfrm>
+          <a:prstGeom prst="rect">
+            <a:avLst/>
+          </a:prstGeom>
+        </p:spPr>
+      </p:pic>
       <p:cxnSp>
         <p:nvCxnSpPr>
-          <p:cNvPr id="19" name="Connector 18"/>
+          <p:cNvPr id="20" name="Connector 19"/>
           <p:cNvCxnSpPr/>
           <p:nvPr/>
         </p:nvCxnSpPr>
@@ -9739,7 +9859,7 @@
       </p:cxnSp>
       <p:sp>
         <p:nvSpPr>
-          <p:cNvPr id="20" name="Oval 19"/>
+          <p:cNvPr id="21" name="Oval 20"/>
           <p:cNvSpPr/>
           <p:nvPr/>
         </p:nvSpPr>
@@ -9784,7 +9904,7 @@
       </p:sp>
       <p:sp>
         <p:nvSpPr>
-          <p:cNvPr id="21" name="Oval 20"/>
+          <p:cNvPr id="22" name="Oval 21"/>
           <p:cNvSpPr/>
           <p:nvPr/>
         </p:nvSpPr>
@@ -9829,7 +9949,7 @@
       </p:sp>
       <p:sp>
         <p:nvSpPr>
-          <p:cNvPr id="22" name="Oval 21"/>
+          <p:cNvPr id="23" name="Oval 22"/>
           <p:cNvSpPr/>
           <p:nvPr/>
         </p:nvSpPr>
@@ -9874,7 +9994,7 @@
       </p:sp>
       <p:sp>
         <p:nvSpPr>
-          <p:cNvPr id="23" name="Oval 22"/>
+          <p:cNvPr id="24" name="Oval 23"/>
           <p:cNvSpPr/>
           <p:nvPr/>
         </p:nvSpPr>
@@ -9919,7 +10039,7 @@
       </p:sp>
       <p:sp>
         <p:nvSpPr>
-          <p:cNvPr id="24" name="Oval 23"/>
+          <p:cNvPr id="25" name="Oval 24"/>
           <p:cNvSpPr/>
           <p:nvPr/>
         </p:nvSpPr>
@@ -9964,7 +10084,7 @@
       </p:sp>
       <p:sp>
         <p:nvSpPr>
-          <p:cNvPr id="25" name="TextBox 24"/>
+          <p:cNvPr id="26" name="TextBox 25"/>
           <p:cNvSpPr txBox="1"/>
           <p:nvPr/>
         </p:nvSpPr>
@@ -10080,7 +10200,7 @@
           <a:p>
             <a:r>
               <a:rPr/>
-              <a:t>[1] London Offices Spotlight Q2 2026 (Uploaded by PoC seed · 2026-10-10) - https://www.knightfrank.co.uk/site-assets/research/report-pdfs/london-office-spotlight/spotlight-q2-2026.pdf</a:t>
+              <a:t>[1] London Offices Spotlight Q2 2026 (Uploaded by PoC seed · 2026-10-11) - https://www.knightfrank.co.uk/site-assets/research/report-pdfs/london-office-spotlight/spotlight-q2-2026.pdf</a:t>
             </a:r>
           </a:p>
           <a:p>
@@ -10092,43 +10212,43 @@
           <a:p>
             <a:r>
               <a:rPr/>
-              <a:t>[3] The London Office Market Report Q1 2024 (Uploaded by PoC seed · 2026-10-10) - https://content.knightfrank.com/research/104/documents/en/the-london-office-market-report-q1-2024-11170.pdf</a:t>
+              <a:t>[3] The London Office Market Report Q1 2024 (Uploaded by PoC seed · 2026-10-11) - https://content.knightfrank.com/research/104/documents/en/the-london-office-market-report-q1-2024-11170.pdf</a:t>
             </a:r>
           </a:p>
           <a:p>
             <a:r>
               <a:rPr/>
-              <a:t>[4] London Offices Spotlight Q2 2024 (Uploaded by PoC seed · 2026-10-10) - https://content.knightfrank.com/research/1903/documents/en/london-offices-spotlight-q2-2024-11338.pdf</a:t>
+              <a:t>[4] London Offices Spotlight Q2 2024 (Uploaded by PoC seed · 2026-10-11) - https://content.knightfrank.com/research/1903/documents/en/london-offices-spotlight-q2-2024-11338.pdf</a:t>
             </a:r>
           </a:p>
           <a:p>
             <a:r>
               <a:rPr/>
-              <a:t>[5] The London Office Market Report Q3 2024 (Uploaded by PoC seed · 2026-10-10) - https://www.knightfrank.co.uk/research/reports/the-london-office-market-report-104/contentassets/the-london-office-market-report-q3-2024-11701.pdf</a:t>
+              <a:t>[5] The London Office Market Report Q3 2024 (Uploaded by PoC seed · 2026-10-11) - https://www.knightfrank.co.uk/research/reports/the-london-office-market-report-104/contentassets/the-london-office-market-report-q3-2024-11701.pdf</a:t>
             </a:r>
           </a:p>
           <a:p>
             <a:r>
               <a:rPr/>
-              <a:t>[6] The London Office Market Report Q2 2025 (Uploaded by PoC seed · 2026-10-10) - https://content.knightfrank.com/research/104/documents/en/the-london-office-market-report-q2-2025-12541.pdf</a:t>
+              <a:t>[6] The London Office Market Report Q2 2025 (Uploaded by PoC seed · 2026-10-11) - https://content.knightfrank.com/research/104/documents/en/the-london-office-market-report-q2-2025-12541.pdf</a:t>
             </a:r>
           </a:p>
           <a:p>
             <a:r>
               <a:rPr/>
-              <a:t>[7] London Offices Spotlight Q3 2025 (Uploaded by PoC seed · 2026-10-10) - https://content.knightfrank.com/research/1903/documents/en/london-offices-spotlight-q3-2025-12540.pdf</a:t>
+              <a:t>[7] London Offices Spotlight Q3 2025 (Uploaded by PoC seed · 2026-10-11) - https://content.knightfrank.com/research/1903/documents/en/london-offices-spotlight-q3-2025-12540.pdf</a:t>
             </a:r>
           </a:p>
           <a:p>
             <a:r>
               <a:rPr/>
-              <a:t>[8] London Offices Spotlight Q4 2025 (Uploaded by PoC seed · 2026-10-10) - https://www.knightfrank.co.uk/site-assets/research/report-pdfs/spotlight/spotlight-q4-2025-2.pdf</a:t>
+              <a:t>[8] London Offices Spotlight Q4 2025 (Uploaded by PoC seed · 2026-10-11) - https://www.knightfrank.co.uk/site-assets/research/report-pdfs/spotlight/spotlight-q4-2025-2.pdf</a:t>
             </a:r>
           </a:p>
           <a:p>
             <a:r>
               <a:rPr/>
-              <a:t>[9] London Offices Spotlight Q1 2026 (Uploaded by PoC seed · 2026-10-10) - https://www.knightfrank.co.uk/site-assets/research/report-pdfs/london-office-spotlight/spotlight-q1-2026v3.pdf</a:t>
+              <a:t>[9] London Offices Spotlight Q1 2026 (Uploaded by PoC seed · 2026-10-11) - https://www.knightfrank.co.uk/site-assets/research/report-pdfs/london-office-spotlight/spotlight-q1-2026v3.pdf</a:t>
             </a:r>
           </a:p>
           <a:p>
@@ -10155,9 +10275,33 @@
           </a:p>
         </p:txBody>
       </p:sp>
-      <p:sp>
-        <p:nvSpPr>
-          <p:cNvPr id="5" name="tier dot open"/>
+      <p:pic>
+        <p:nvPicPr>
+          <p:cNvPr id="5" name="app icon" descr="app-icon-1024.png"/>
+          <p:cNvPicPr>
+            <a:picLocks noChangeAspect="1"/>
+          </p:cNvPicPr>
+          <p:nvPr/>
+        </p:nvPicPr>
+        <p:blipFill>
+          <a:blip r:embed="rId2"/>
+          <a:stretch>
+            <a:fillRect/>
+          </a:stretch>
+        </p:blipFill>
+        <p:spPr>
+          <a:xfrm>
+            <a:off x="10607040" y="6455664"/>
+            <a:ext cx="274320" cy="274320"/>
+          </a:xfrm>
+          <a:prstGeom prst="rect">
+            <a:avLst/>
+          </a:prstGeom>
+        </p:spPr>
+      </p:pic>
+      <p:sp>
+        <p:nvSpPr>
+          <p:cNvPr id="6" name="tier dot open"/>
           <p:cNvSpPr/>
           <p:nvPr/>
         </p:nvSpPr>
@@ -10200,7 +10344,7 @@
       </p:sp>
       <p:sp>
         <p:nvSpPr>
-          <p:cNvPr id="6" name="TextBox 5"/>
+          <p:cNvPr id="7" name="TextBox 6"/>
           <p:cNvSpPr txBox="1"/>
           <p:nvPr/>
         </p:nvSpPr>
@@ -10233,7 +10377,7 @@
       </p:sp>
       <p:sp>
         <p:nvSpPr>
-          <p:cNvPr id="7" name="tier dot uploaded"/>
+          <p:cNvPr id="8" name="tier dot uploaded"/>
           <p:cNvSpPr/>
           <p:nvPr/>
         </p:nvSpPr>
@@ -10276,7 +10420,7 @@
       </p:sp>
       <p:sp>
         <p:nvSpPr>
-          <p:cNvPr id="8" name="TextBox 7"/>
+          <p:cNvPr id="9" name="TextBox 8"/>
           <p:cNvSpPr txBox="1"/>
           <p:nvPr/>
         </p:nvSpPr>
@@ -10309,7 +10453,7 @@
       </p:sp>
       <p:sp>
         <p:nvSpPr>
-          <p:cNvPr id="9" name="tier dot internal"/>
+          <p:cNvPr id="10" name="tier dot internal"/>
           <p:cNvSpPr/>
           <p:nvPr/>
         </p:nvSpPr>
@@ -10352,7 +10496,7 @@
       </p:sp>
       <p:sp>
         <p:nvSpPr>
-          <p:cNvPr id="10" name="TextBox 9"/>
+          <p:cNvPr id="11" name="TextBox 10"/>
           <p:cNvSpPr txBox="1"/>
           <p:nvPr/>
         </p:nvSpPr>
@@ -10385,7 +10529,7 @@
       </p:sp>
       <p:sp>
         <p:nvSpPr>
-          <p:cNvPr id="11" name="TextBox 10"/>
+          <p:cNvPr id="12" name="TextBox 11"/>
           <p:cNvSpPr txBox="1"/>
           <p:nvPr/>
         </p:nvSpPr>

</xml_diff>